<commit_message>
0.4.2: readable section colors, ask bar hover fix, color audit
- Card-mode sections: in light theme, light colors (mint) are darkened
  until labels reach 4.5:1 and borders 3:1 on white. Canvas, PNG/SVG and
  PowerPoint export all use the same rule; dark theme and official AWS
  group colors are unchanged.
- Ask bar: hover style no longer applies to the open input bar (it turned
  the bar dark blue and hid the placeholder text).
- Light muted text color darkened (#6b7280 -> #5b6472) for 4.5:1 on gray.
- tools/contrast_audit.js + contrast_states.js: contrast scan of visible
  text, placeholders and hover rules across panels, light and dark.
- Manual slide deck updated with GitHub download and update instructions.

Co-Authored-By: Claude Opus 5.5 <noreply@anthropic.com>
</commit_message>
<xml_diff>
--- a/docs/Arch_Canvas_사용설명서.pptx
+++ b/docs/Arch_Canvas_사용설명서.pptx
@@ -3296,7 +3296,7 @@
                 <a:ea typeface="프리젠테이션 5 Medium" pitchFamily="2" charset="-127"/>
                 <a:hlinkClick r:id="rId2"/>
               </a:rPr>
-              <a:t>https://drive.google.com/drive/u/0/folders/1xL_eoanDm8HskDvOP5ATm6ZZF-_TKdRp</a:t>
+              <a:t>https://github.com/svalu/arch-canvas/releases/latest</a:t>
             </a:r>
           </a:p>
         </p:txBody>
@@ -3339,7 +3339,7 @@
         <p:spPr>
           <a:xfrm>
             <a:off x="317500" y="3708400"/>
-            <a:ext cx="4381500" cy="1143000"/>
+            <a:ext cx="4381500" cy="2100000"/>
           </a:xfrm>
           <a:prstGeom prst="rect">
             <a:avLst/>
@@ -3382,7 +3382,7 @@
                 <a:latin typeface="Pretendard Medium"/>
                 <a:ea typeface="Pretendard Medium"/>
               </a:rPr>
-              <a:t>유닛 공유드라이브 → </a:t>
+              <a:t>깃허브 → </a:t>
             </a:r>
             <a:r>
               <a:rPr sz="950" b="0">
@@ -3393,7 +3393,7 @@
                 <a:ea typeface="Pretendard SemiBold"/>
                 <a:hlinkClick r:id="rId2"/>
               </a:rPr>
-              <a:t>Arch Canvas 폴더 열기</a:t>
+              <a:t>최신 버전 받기 (Arch_Canvas_v….zip)</a:t>
             </a:r>
           </a:p>
           <a:p>
@@ -3410,7 +3410,7 @@
                 <a:latin typeface="Pretendard Medium"/>
                 <a:ea typeface="Pretendard Medium"/>
               </a:rPr>
-              <a:t>Arch Canvas.exe 하나만 받으면 돼요 (data 폴더는 실행하면 자동 생성)</a:t>
+              <a:t>zip 풀고 Arch Canvas.exe 실행 (data 폴더는 실행하면 자동 생성)</a:t>
             </a:r>
           </a:p>
           <a:p>
@@ -3450,6 +3450,110 @@
               </a:rPr>
               <a:t> 공식 패키지 · 백신이 막으면 허용</a:t>
             </a:r>
+          </a:p>
+          <a:p>
+            <a:pPr>
+              <a:lnSpc>
+                <a:spcPct val="60000"/>
+              </a:lnSpc>
+            </a:pPr>
+            <a:endParaRPr sz="950"/>
+          </a:p>
+          <a:p>
+            <a:pPr>
+              <a:lnSpc>
+                <a:spcPct val="120000"/>
+              </a:lnSpc>
+            </a:pPr>
+            <a:r>
+              <a:rPr sz="1050" b="0">
+                <a:solidFill>
+                  <a:srgbClr val="1C1C1C"/>
+                </a:solidFill>
+                <a:latin typeface="Pretendard SemiBold"/>
+                <a:ea typeface="Pretendard SemiBold"/>
+              </a:rPr>
+              <a:t>업데이트</a:t>
+            </a:r>
+          </a:p>
+          <a:p>
+            <a:pPr>
+              <a:lnSpc>
+                <a:spcPct val="120000"/>
+              </a:lnSpc>
+            </a:pPr>
+            <a:r>
+              <a:rPr sz="950" b="0">
+                <a:solidFill>
+                  <a:srgbClr val="595959"/>
+                </a:solidFill>
+                <a:latin typeface="Pretendard Medium"/>
+                <a:ea typeface="Pretendard Medium"/>
+              </a:rPr>
+              <a:t>앱 상단 [?] 도움말 → 맨 아래 [업데이트 확인] — 받고 다시 시작까지 자동이에요</a:t>
+            </a:r>
+          </a:p>
+          <a:p>
+            <a:pPr>
+              <a:lnSpc>
+                <a:spcPct val="120000"/>
+              </a:lnSpc>
+            </a:pPr>
+            <a:r>
+              <a:rPr sz="950" b="0">
+                <a:solidFill>
+                  <a:srgbClr val="595959"/>
+                </a:solidFill>
+                <a:latin typeface="Pretendard Medium"/>
+                <a:ea typeface="Pretendard Medium"/>
+              </a:rPr>
+              <a:t>새 버전이 나오면 툴바에 </a:t>
+            </a:r>
+            <a:r>
+              <a:rPr sz="950" b="0">
+                <a:solidFill>
+                  <a:srgbClr val="4154FF"/>
+                </a:solidFill>
+                <a:latin typeface="Pretendard SemiBold"/>
+                <a:ea typeface="Pretendard SemiBold"/>
+              </a:rPr>
+              <a:t>새 버전 0.x</a:t>
+            </a:r>
+            <a:r>
+              <a:rPr sz="950" b="0">
+                <a:solidFill>
+                  <a:srgbClr val="595959"/>
+                </a:solidFill>
+                <a:latin typeface="Pretendard Medium"/>
+                <a:ea typeface="Pretendard Medium"/>
+              </a:rPr>
+              <a:t> 칩이 떠요 → 누르고 [지금 업데이트]</a:t>
+            </a:r>
+          </a:p>
+          <a:p>
+            <a:pPr>
+              <a:lnSpc>
+                <a:spcPct val="120000"/>
+              </a:lnSpc>
+            </a:pPr>
+            <a:r>
+              <a:rPr sz="950" b="0">
+                <a:solidFill>
+                  <a:srgbClr val="595959"/>
+                </a:solidFill>
+                <a:latin typeface="Pretendard Medium"/>
+                <a:ea typeface="Pretendard Medium"/>
+              </a:rPr>
+              <a:t>작업 내용은 그대로 남아요 · 0.3 이하는 위 주소에서 한 번만 새로 받아 주세요</a:t>
+            </a:r>
+          </a:p>
+          <a:p>
+            <a:pPr>
+              <a:lnSpc>
+                <a:spcPct val="60000"/>
+              </a:lnSpc>
+            </a:pPr>
+            <a:endParaRPr sz="950"/>
           </a:p>
           <a:p>
             <a:pPr>

</xml_diff>